<commit_message>
Final slides and report
</commit_message>
<xml_diff>
--- a/Project1/Reports/Jegede_project1_slides.pptx
+++ b/Project1/Reports/Jegede_project1_slides.pptx
@@ -3477,16 +3477,28 @@
             <p:ph idx="1"/>
           </p:nvPr>
         </p:nvSpPr>
-        <p:spPr/>
+        <p:spPr>
+          <a:xfrm>
+            <a:off x="838200" y="1825624"/>
+            <a:ext cx="10515600" cy="4948801"/>
+          </a:xfrm>
+        </p:spPr>
         <p:txBody>
           <a:bodyPr>
-            <a:normAutofit/>
+            <a:normAutofit lnSpcReduction="10000"/>
           </a:bodyPr>
           <a:lstStyle/>
           <a:p>
             <a:r>
               <a:rPr lang="en-US" dirty="0"/>
-              <a:t>For each of these outcomes, </a:t>
+              <a:t>For each of the four outcome measures</a:t>
+            </a:r>
+          </a:p>
+          <a:p>
+            <a:pPr lvl="1"/>
+            <a:r>
+              <a:rPr lang="en-US" dirty="0"/>
+              <a:t>Q1: Does the outcome at 2 years after HAART differ by hard drug use status at baseline?</a:t>
             </a:r>
           </a:p>
           <a:p>
@@ -3497,7 +3509,7 @@
             <a:pPr lvl="1"/>
             <a:r>
               <a:rPr lang="en-US" dirty="0"/>
-              <a:t>Q1: Does the outcome at 2 years after HAART differ by hard drug use status at baseline?</a:t>
+              <a:t>Q2: Is this difference explained by adherence (to medications taken since last visit) status at year 2</a:t>
             </a:r>
           </a:p>
           <a:p>
@@ -3505,14 +3517,31 @@
             <a:endParaRPr lang="en-US" dirty="0"/>
           </a:p>
           <a:p>
+            <a:r>
+              <a:rPr lang="en-US" dirty="0"/>
+              <a:t>Variables</a:t>
+            </a:r>
+          </a:p>
+          <a:p>
             <a:pPr lvl="1"/>
             <a:r>
               <a:rPr lang="en-US" dirty="0"/>
-              <a:t>Q2: Is this difference explained by adherence (to medications taken since last visit) status at year 2</a:t>
-            </a:r>
-          </a:p>
-          <a:p>
-            <a:endParaRPr lang="en-US" dirty="0"/>
+              <a:t>Outcomes: aggregate physical QoL, mental QoL, CD4+ T-cell counts, and standardized viral load (copies/mL of blood)</a:t>
+            </a:r>
+          </a:p>
+          <a:p>
+            <a:pPr lvl="1"/>
+            <a:r>
+              <a:rPr lang="en-US" dirty="0"/>
+              <a:t>Key predictor: baseline hard drug use status</a:t>
+            </a:r>
+          </a:p>
+          <a:p>
+            <a:pPr lvl="1"/>
+            <a:r>
+              <a:rPr lang="en-US" dirty="0"/>
+              <a:t>Covariates: body mass index (BMI), age, race/ethnicity, education and smoking status </a:t>
+            </a:r>
           </a:p>
         </p:txBody>
       </p:sp>
@@ -3596,64 +3625,72 @@
             <p:ph idx="1"/>
           </p:nvPr>
         </p:nvSpPr>
-        <p:spPr/>
+        <p:spPr>
+          <a:xfrm>
+            <a:off x="838200" y="1412671"/>
+            <a:ext cx="10515600" cy="4351338"/>
+          </a:xfrm>
+        </p:spPr>
         <p:txBody>
           <a:bodyPr>
-            <a:normAutofit fontScale="55000" lnSpcReduction="20000"/>
+            <a:noAutofit/>
           </a:bodyPr>
           <a:lstStyle/>
           <a:p>
             <a:r>
-              <a:rPr lang="en-US" dirty="0"/>
+              <a:rPr lang="en-US" sz="1800" dirty="0"/>
               <a:t>Demographic, laboratory, and quality of life (QoL) measures on 715 unique study participants (men) for up to 8 years</a:t>
             </a:r>
           </a:p>
           <a:p>
             <a:pPr lvl="1"/>
             <a:r>
-              <a:rPr lang="en-US" dirty="0"/>
+              <a:rPr lang="en-US" sz="1800" dirty="0"/>
               <a:t>Comprising 3935 observations</a:t>
             </a:r>
           </a:p>
           <a:p>
-            <a:r>
-              <a:rPr lang="en-US" dirty="0"/>
+            <a:endParaRPr lang="en-US" sz="1800" dirty="0"/>
+          </a:p>
+          <a:p>
+            <a:r>
+              <a:rPr lang="en-US" sz="1800" dirty="0"/>
               <a:t>Data was limited to the baseline (unique n=715) and year 2 follow-up timepoints (unique n=506)</a:t>
             </a:r>
           </a:p>
           <a:p>
-            <a:endParaRPr lang="en-US" dirty="0"/>
-          </a:p>
-          <a:p>
-            <a:r>
-              <a:rPr lang="en-US" dirty="0"/>
+            <a:endParaRPr lang="en-US" sz="1800" dirty="0"/>
+          </a:p>
+          <a:p>
+            <a:r>
+              <a:rPr lang="en-US" sz="1800" dirty="0"/>
               <a:t>Treatment response variables include aggregate physical QoL score, mental QoL score, and CD4+ T-cell counts (cells/ml), and log10 standardized viral load (in copies/mL of blood)</a:t>
             </a:r>
           </a:p>
           <a:p>
-            <a:endParaRPr lang="en-US" dirty="0"/>
-          </a:p>
-          <a:p>
-            <a:r>
-              <a:rPr lang="en-US" dirty="0"/>
-              <a:t>Based on the (right) skew distribution of log10 standardized viral load, it was log transformed for analysis.</a:t>
-            </a:r>
-          </a:p>
-          <a:p>
-            <a:endParaRPr lang="en-US" dirty="0"/>
-          </a:p>
-          <a:p>
-            <a:r>
-              <a:rPr lang="en-US" dirty="0"/>
+            <a:endParaRPr lang="en-US" sz="1800" dirty="0"/>
+          </a:p>
+          <a:p>
+            <a:r>
+              <a:rPr lang="en-US" sz="1800" dirty="0"/>
+              <a:t>Based on the (right) skew distribution of standardized viral load, it was log10 transformed for analysis.</a:t>
+            </a:r>
+          </a:p>
+          <a:p>
+            <a:endParaRPr lang="en-US" sz="1800" dirty="0"/>
+          </a:p>
+          <a:p>
+            <a:r>
+              <a:rPr lang="en-US" sz="1800" dirty="0"/>
               <a:t>43 of 506 observations with missing values for predictors and outcomes of interest were excluded for analysis, the remaining samples (n=463) was used for frequentist and Bayesian analysis</a:t>
             </a:r>
           </a:p>
           <a:p>
-            <a:endParaRPr lang="en-US" dirty="0"/>
-          </a:p>
-          <a:p>
-            <a:r>
-              <a:rPr lang="en-US" dirty="0"/>
+            <a:endParaRPr lang="en-US" sz="1800" dirty="0"/>
+          </a:p>
+          <a:p>
+            <a:r>
+              <a:rPr lang="en-US" sz="1800" dirty="0"/>
               <a:t>Box plots for graphical display of distribution, means/SD for location/spread, and frequency/proportion for categorical variables</a:t>
             </a:r>
           </a:p>
@@ -3739,10 +3776,15 @@
             <p:ph idx="1"/>
           </p:nvPr>
         </p:nvSpPr>
-        <p:spPr/>
+        <p:spPr>
+          <a:xfrm>
+            <a:off x="838200" y="1327356"/>
+            <a:ext cx="10515600" cy="5378244"/>
+          </a:xfrm>
+        </p:spPr>
         <p:txBody>
           <a:bodyPr>
-            <a:normAutofit fontScale="85000" lnSpcReduction="10000"/>
+            <a:normAutofit fontScale="92500" lnSpcReduction="20000"/>
           </a:bodyPr>
           <a:lstStyle/>
           <a:p>
@@ -3762,14 +3804,14 @@
             <a:pPr lvl="1"/>
             <a:r>
               <a:rPr lang="en-US" dirty="0"/>
-              <a:t>Report probability of observing a clinically meaning effect</a:t>
+              <a:t>Posterior probability of a clinically meaning effect</a:t>
             </a:r>
           </a:p>
           <a:p>
             <a:pPr lvl="1"/>
             <a:r>
               <a:rPr lang="en-US" dirty="0"/>
-              <a:t>Primarily Bayesian analysis in Stan; frequentist for comparing results</a:t>
+              <a:t>Primarily Bayesian analysis in Stan; compared to frequentist results</a:t>
             </a:r>
           </a:p>
           <a:p>
@@ -3780,6 +3822,9 @@
             </a:r>
           </a:p>
           <a:p>
+            <a:endParaRPr lang="en-US" dirty="0"/>
+          </a:p>
+          <a:p>
             <a:r>
               <a:rPr lang="en-US" dirty="0"/>
               <a:t>Q2: Is this difference explained by adherence (to medications taken since last visit) status at year 2?</a:t>
@@ -3810,7 +3855,7 @@
             <a:pPr lvl="1"/>
             <a:r>
               <a:rPr lang="en-US" dirty="0"/>
-              <a:t>Primarily Bayesian analysis in Stan; frequentist for comparing results</a:t>
+              <a:t>Primarily Bayesian analysis in Stan; compared to frequentist results</a:t>
             </a:r>
           </a:p>
           <a:p>
@@ -3988,10 +4033,10 @@
       </p:sp>
       <p:pic>
         <p:nvPicPr>
-          <p:cNvPr id="6" name="Picture 5">
-            <a:extLst>
-              <a:ext uri="{FF2B5EF4-FFF2-40B4-BE49-F238E27FC236}">
-                <a16:creationId xmlns:a16="http://schemas.microsoft.com/office/drawing/2014/main" id="{E4B7E91B-9B63-B61F-70DD-5EB09B8CBA7F}"/>
+          <p:cNvPr id="8" name="Picture 7">
+            <a:extLst>
+              <a:ext uri="{FF2B5EF4-FFF2-40B4-BE49-F238E27FC236}">
+                <a16:creationId xmlns:a16="http://schemas.microsoft.com/office/drawing/2014/main" id="{810D500C-3D17-4EAA-AEA9-31441CA96603}"/>
               </a:ext>
             </a:extLst>
           </p:cNvPr>
@@ -4008,8 +4053,8 @@
         </p:blipFill>
         <p:spPr>
           <a:xfrm>
-            <a:off x="7494139" y="21587"/>
-            <a:ext cx="4697861" cy="4443090"/>
+            <a:off x="174584" y="1347149"/>
+            <a:ext cx="6093330" cy="3657470"/>
           </a:xfrm>
           <a:prstGeom prst="rect">
             <a:avLst/>
@@ -4018,10 +4063,10 @@
       </p:pic>
       <p:pic>
         <p:nvPicPr>
-          <p:cNvPr id="8" name="Picture 7">
-            <a:extLst>
-              <a:ext uri="{FF2B5EF4-FFF2-40B4-BE49-F238E27FC236}">
-                <a16:creationId xmlns:a16="http://schemas.microsoft.com/office/drawing/2014/main" id="{810D500C-3D17-4EAA-AEA9-31441CA96603}"/>
+          <p:cNvPr id="13" name="Picture 12">
+            <a:extLst>
+              <a:ext uri="{FF2B5EF4-FFF2-40B4-BE49-F238E27FC236}">
+                <a16:creationId xmlns:a16="http://schemas.microsoft.com/office/drawing/2014/main" id="{AE322B97-9AE1-2057-1130-27F447371122}"/>
               </a:ext>
             </a:extLst>
           </p:cNvPr>
@@ -4038,8 +4083,8 @@
         </p:blipFill>
         <p:spPr>
           <a:xfrm>
-            <a:off x="382653" y="1347149"/>
-            <a:ext cx="5359547" cy="3217023"/>
+            <a:off x="6403784" y="901957"/>
+            <a:ext cx="5613632" cy="5275006"/>
           </a:xfrm>
           <a:prstGeom prst="rect">
             <a:avLst/>
@@ -4048,10 +4093,10 @@
       </p:pic>
       <p:pic>
         <p:nvPicPr>
-          <p:cNvPr id="10" name="Picture 9">
-            <a:extLst>
-              <a:ext uri="{FF2B5EF4-FFF2-40B4-BE49-F238E27FC236}">
-                <a16:creationId xmlns:a16="http://schemas.microsoft.com/office/drawing/2014/main" id="{89EB2696-7150-3F8D-15D4-C6DD4E120E4C}"/>
+          <p:cNvPr id="5" name="Picture 4">
+            <a:extLst>
+              <a:ext uri="{FF2B5EF4-FFF2-40B4-BE49-F238E27FC236}">
+                <a16:creationId xmlns:a16="http://schemas.microsoft.com/office/drawing/2014/main" id="{DECFA0D1-E3FB-D509-0492-839198554B69}"/>
               </a:ext>
             </a:extLst>
           </p:cNvPr>
@@ -4068,44 +4113,71 @@
         </p:blipFill>
         <p:spPr>
           <a:xfrm>
-            <a:off x="200788" y="5341529"/>
-            <a:ext cx="5895212" cy="1494885"/>
+            <a:off x="174584" y="5347216"/>
+            <a:ext cx="6021131" cy="1489198"/>
           </a:xfrm>
           <a:prstGeom prst="rect">
             <a:avLst/>
           </a:prstGeom>
         </p:spPr>
       </p:pic>
-      <p:pic>
-        <p:nvPicPr>
-          <p:cNvPr id="13" name="Picture 12">
-            <a:extLst>
-              <a:ext uri="{FF2B5EF4-FFF2-40B4-BE49-F238E27FC236}">
-                <a16:creationId xmlns:a16="http://schemas.microsoft.com/office/drawing/2014/main" id="{AE322B97-9AE1-2057-1130-27F447371122}"/>
-              </a:ext>
-            </a:extLst>
-          </p:cNvPr>
-          <p:cNvPicPr>
-            <a:picLocks noChangeAspect="1"/>
-          </p:cNvPicPr>
+      <p:sp>
+        <p:nvSpPr>
+          <p:cNvPr id="4" name="Rectangle: Rounded Corners 3">
+            <a:extLst>
+              <a:ext uri="{FF2B5EF4-FFF2-40B4-BE49-F238E27FC236}">
+                <a16:creationId xmlns:a16="http://schemas.microsoft.com/office/drawing/2014/main" id="{97A820E7-240D-A5AB-F8C7-70B27F3257B2}"/>
+              </a:ext>
+            </a:extLst>
+          </p:cNvPr>
+          <p:cNvSpPr/>
           <p:nvPr/>
-        </p:nvPicPr>
-        <p:blipFill>
-          <a:blip r:embed="rId5"/>
-          <a:stretch>
-            <a:fillRect/>
-          </a:stretch>
-        </p:blipFill>
+        </p:nvSpPr>
         <p:spPr>
           <a:xfrm>
-            <a:off x="7494139" y="4525556"/>
-            <a:ext cx="4552774" cy="2332444"/>
+            <a:off x="7098889" y="344129"/>
+            <a:ext cx="3854245" cy="557828"/>
           </a:xfrm>
-          <a:prstGeom prst="rect">
+          <a:prstGeom prst="roundRect">
             <a:avLst/>
           </a:prstGeom>
+          <a:noFill/>
+          <a:ln>
+            <a:noFill/>
+          </a:ln>
         </p:spPr>
-      </p:pic>
+        <p:style>
+          <a:lnRef idx="2">
+            <a:schemeClr val="accent1">
+              <a:shade val="15000"/>
+            </a:schemeClr>
+          </a:lnRef>
+          <a:fillRef idx="1">
+            <a:schemeClr val="accent1"/>
+          </a:fillRef>
+          <a:effectRef idx="0">
+            <a:schemeClr val="accent1"/>
+          </a:effectRef>
+          <a:fontRef idx="minor">
+            <a:schemeClr val="lt1"/>
+          </a:fontRef>
+        </p:style>
+        <p:txBody>
+          <a:bodyPr rtlCol="0" anchor="ctr"/>
+          <a:lstStyle/>
+          <a:p>
+            <a:pPr algn="ctr"/>
+            <a:r>
+              <a:rPr lang="en-US" dirty="0">
+                <a:solidFill>
+                  <a:schemeClr val="tx1"/>
+                </a:solidFill>
+              </a:rPr>
+              <a:t>Fig. 1: Treatment response by hard drug use and study period</a:t>
+            </a:r>
+          </a:p>
+        </p:txBody>
+      </p:sp>
     </p:spTree>
     <p:extLst>
       <p:ext uri="{BB962C8B-B14F-4D97-AF65-F5344CB8AC3E}">
@@ -4339,10 +4411,15 @@
             <p:ph idx="1"/>
           </p:nvPr>
         </p:nvSpPr>
-        <p:spPr/>
+        <p:spPr>
+          <a:xfrm>
+            <a:off x="838200" y="1219200"/>
+            <a:ext cx="10515600" cy="5638800"/>
+          </a:xfrm>
+        </p:spPr>
         <p:txBody>
           <a:bodyPr>
-            <a:normAutofit/>
+            <a:normAutofit fontScale="92500" lnSpcReduction="10000"/>
           </a:bodyPr>
           <a:lstStyle/>
           <a:p>
@@ -4373,21 +4450,51 @@
             </a:r>
           </a:p>
           <a:p>
+            <a:pPr lvl="2"/>
+            <a:endParaRPr lang="en-US" dirty="0"/>
+          </a:p>
+          <a:p>
             <a:r>
               <a:rPr lang="en-US" dirty="0"/>
-              <a:t>Q2: </a:t>
-            </a:r>
-            <a:r>
-              <a:rPr lang="en-US"/>
-              <a:t>Mediation analysis</a:t>
-            </a:r>
-            <a:endParaRPr lang="en-US" dirty="0"/>
+              <a:t>Q2: Mediation analysis</a:t>
+            </a:r>
           </a:p>
           <a:p>
             <a:pPr lvl="1"/>
             <a:r>
               <a:rPr lang="en-US" dirty="0"/>
               <a:t>Based on the indicated criteria, there was no substantial difference in the point estimates between the crude and adjusted models. Therefore, treatment adherence is not a mediator </a:t>
+            </a:r>
+          </a:p>
+          <a:p>
+            <a:pPr lvl="1"/>
+            <a:endParaRPr lang="en-US" dirty="0"/>
+          </a:p>
+          <a:p>
+            <a:r>
+              <a:rPr lang="en-US" dirty="0"/>
+              <a:t>Limitations:</a:t>
+            </a:r>
+          </a:p>
+          <a:p>
+            <a:pPr lvl="1"/>
+            <a:r>
+              <a:rPr lang="en-US" dirty="0"/>
+              <a:t>Loss to follow-up, especially for hard drug users at baseline</a:t>
+            </a:r>
+          </a:p>
+          <a:p>
+            <a:pPr lvl="1"/>
+            <a:r>
+              <a:rPr lang="en-US" dirty="0"/>
+              <a:t>Evidence of a change in patient population between baseline and year 2</a:t>
+            </a:r>
+          </a:p>
+          <a:p>
+            <a:pPr lvl="2"/>
+            <a:r>
+              <a:rPr lang="en-US" dirty="0"/>
+              <a:t>For example BMI, CD4+ T-cell count</a:t>
             </a:r>
           </a:p>
         </p:txBody>

</xml_diff>